<commit_message>
Update 단어 스피드 퀴즈 assets, add ZIP slides and scoring tip
Co-Authored-By: Claude Opus 4.6 (1M context) <noreply@anthropic.com>
</commit_message>
<xml_diff>
--- a/public/downloads/games/word-speed-quiz/rules.pptx
+++ b/public/downloads/games/word-speed-quiz/rules.pptx
@@ -31,16 +31,12 @@
   <p:notesSz cx="6858000" cy="9144000"/>
   <p:embeddedFontLst>
     <p:embeddedFont>
-      <p:font typeface="Jua" charset="1" panose="00000000000000000000"/>
+      <p:font typeface="무궁화 고딕" charset="1" panose="02020603020101020101"/>
       <p:regular r:id="rId27"/>
     </p:embeddedFont>
     <p:embeddedFont>
-      <p:font typeface="TDTD갬성명조" charset="1" panose="02000503000000000000"/>
+      <p:font typeface="무궁화 고딕 Bold" charset="1" panose="02020603020101020101"/>
       <p:regular r:id="rId28"/>
-    </p:embeddedFont>
-    <p:embeddedFont>
-      <p:font typeface="TDTD가온" charset="1" panose="02000503000000000000"/>
-      <p:regular r:id="rId29"/>
     </p:embeddedFont>
   </p:embeddedFontLst>
   <p:defaultTextStyle>
@@ -3158,8 +3154,8 @@
         </p:nvSpPr>
         <p:spPr>
           <a:xfrm rot="0">
-            <a:off x="1028700" y="3892867"/>
-            <a:ext cx="15555091" cy="2200275"/>
+            <a:off x="1028700" y="4178617"/>
+            <a:ext cx="15555091" cy="1914525"/>
           </a:xfrm>
           <a:prstGeom prst="rect">
             <a:avLst/>
@@ -3181,10 +3177,10 @@
                 <a:solidFill>
                   <a:srgbClr val="FFFAEF"/>
                 </a:solidFill>
-                <a:latin typeface="Jua"/>
-                <a:ea typeface="Jua"/>
-                <a:cs typeface="Jua"/>
-                <a:sym typeface="Jua"/>
+                <a:latin typeface="무궁화 고딕"/>
+                <a:ea typeface="무궁화 고딕"/>
+                <a:cs typeface="무궁화 고딕"/>
+                <a:sym typeface="무궁화 고딕"/>
               </a:rPr>
               <a:t>단어 스피드 퀴즈</a:t>
             </a:r>
@@ -3199,8 +3195,8 @@
         </p:nvSpPr>
         <p:spPr>
           <a:xfrm rot="0">
-            <a:off x="15264803" y="9812655"/>
-            <a:ext cx="2637975" cy="474345"/>
+            <a:off x="14823645" y="9822180"/>
+            <a:ext cx="3079133" cy="464820"/>
           </a:xfrm>
           <a:prstGeom prst="rect">
             <a:avLst/>
@@ -3225,10 +3221,10 @@
                 <a:solidFill>
                   <a:srgbClr val="FFFFFF"/>
                 </a:solidFill>
-                <a:latin typeface="TDTD갬성명조"/>
-                <a:ea typeface="TDTD갬성명조"/>
-                <a:cs typeface="TDTD갬성명조"/>
-                <a:sym typeface="TDTD갬성명조"/>
+                <a:latin typeface="무궁화 고딕"/>
+                <a:ea typeface="무궁화 고딕"/>
+                <a:cs typeface="무궁화 고딕"/>
+                <a:sym typeface="무궁화 고딕"/>
               </a:rPr>
               <a:t>ⓒ 2026. Sunday Play</a:t>
             </a:r>
@@ -3325,8 +3321,8 @@
         </p:nvSpPr>
         <p:spPr>
           <a:xfrm rot="0">
-            <a:off x="1028700" y="1352550"/>
-            <a:ext cx="15555091" cy="7362825"/>
+            <a:off x="1028700" y="1562100"/>
+            <a:ext cx="15555091" cy="7153275"/>
           </a:xfrm>
           <a:prstGeom prst="rect">
             <a:avLst/>
@@ -3348,10 +3344,10 @@
                 <a:solidFill>
                   <a:srgbClr val="FFFAEF"/>
                 </a:solidFill>
-                <a:latin typeface="Jua"/>
-                <a:ea typeface="Jua"/>
-                <a:cs typeface="Jua"/>
-                <a:sym typeface="Jua"/>
+                <a:latin typeface="무궁화 고딕"/>
+                <a:ea typeface="무궁화 고딕"/>
+                <a:cs typeface="무궁화 고딕"/>
+                <a:sym typeface="무궁화 고딕"/>
               </a:rPr>
               <a:t>플러스(+) 단어 </a:t>
             </a:r>
@@ -3367,10 +3363,10 @@
                 <a:solidFill>
                   <a:srgbClr val="FFFAEF"/>
                 </a:solidFill>
-                <a:latin typeface="Jua"/>
-                <a:ea typeface="Jua"/>
-                <a:cs typeface="Jua"/>
-                <a:sym typeface="Jua"/>
+                <a:latin typeface="무궁화 고딕"/>
+                <a:ea typeface="무궁화 고딕"/>
+                <a:cs typeface="무궁화 고딕"/>
+                <a:sym typeface="무궁화 고딕"/>
               </a:rPr>
               <a:t>: 기도, 찬양, 헌금</a:t>
             </a:r>
@@ -3393,10 +3389,10 @@
                 <a:solidFill>
                   <a:srgbClr val="FFFAEF"/>
                 </a:solidFill>
-                <a:latin typeface="Jua"/>
-                <a:ea typeface="Jua"/>
-                <a:cs typeface="Jua"/>
-                <a:sym typeface="Jua"/>
+                <a:latin typeface="무궁화 고딕"/>
+                <a:ea typeface="무궁화 고딕"/>
+                <a:cs typeface="무궁화 고딕"/>
+                <a:sym typeface="무궁화 고딕"/>
               </a:rPr>
               <a:t>마이너스(-) 단어</a:t>
             </a:r>
@@ -3412,10 +3408,10 @@
                 <a:solidFill>
                   <a:srgbClr val="FFFAEF"/>
                 </a:solidFill>
-                <a:latin typeface="Jua"/>
-                <a:ea typeface="Jua"/>
-                <a:cs typeface="Jua"/>
-                <a:sym typeface="Jua"/>
+                <a:latin typeface="무궁화 고딕"/>
+                <a:ea typeface="무궁화 고딕"/>
+                <a:cs typeface="무궁화 고딕"/>
+                <a:sym typeface="무궁화 고딕"/>
               </a:rPr>
               <a:t>: 졸기, 떠들기, 핸드폰</a:t>
             </a:r>
@@ -3430,8 +3426,8 @@
         </p:nvSpPr>
         <p:spPr>
           <a:xfrm rot="0">
-            <a:off x="15264803" y="9812655"/>
-            <a:ext cx="2637975" cy="474345"/>
+            <a:off x="15264803" y="9822180"/>
+            <a:ext cx="2637975" cy="941070"/>
           </a:xfrm>
           <a:prstGeom prst="rect">
             <a:avLst/>
@@ -3456,10 +3452,10 @@
                 <a:solidFill>
                   <a:srgbClr val="FFFFFF"/>
                 </a:solidFill>
-                <a:latin typeface="TDTD갬성명조"/>
-                <a:ea typeface="TDTD갬성명조"/>
-                <a:cs typeface="TDTD갬성명조"/>
-                <a:sym typeface="TDTD갬성명조"/>
+                <a:latin typeface="무궁화 고딕"/>
+                <a:ea typeface="무궁화 고딕"/>
+                <a:cs typeface="무궁화 고딕"/>
+                <a:sym typeface="무궁화 고딕"/>
               </a:rPr>
               <a:t>ⓒ 2026. Sunday Play</a:t>
             </a:r>
@@ -3506,8 +3502,8 @@
         </p:nvSpPr>
         <p:spPr>
           <a:xfrm rot="0">
-            <a:off x="1108788" y="3895725"/>
-            <a:ext cx="16070423" cy="2200275"/>
+            <a:off x="1108788" y="4181475"/>
+            <a:ext cx="16070423" cy="1914525"/>
           </a:xfrm>
           <a:prstGeom prst="rect">
             <a:avLst/>
@@ -3529,10 +3525,10 @@
                 <a:solidFill>
                   <a:srgbClr val="000000"/>
                 </a:solidFill>
-                <a:latin typeface="Jua"/>
-                <a:ea typeface="Jua"/>
-                <a:cs typeface="Jua"/>
-                <a:sym typeface="Jua"/>
+                <a:latin typeface="무궁화 고딕 Bold"/>
+                <a:ea typeface="무궁화 고딕 Bold"/>
+                <a:cs typeface="무궁화 고딕 Bold"/>
+                <a:sym typeface="무궁화 고딕 Bold"/>
               </a:rPr>
               <a:t>성경에 나오는 먹을 것</a:t>
             </a:r>
@@ -3679,8 +3675,8 @@
         </p:nvSpPr>
         <p:spPr>
           <a:xfrm rot="0">
-            <a:off x="1028700" y="1352550"/>
-            <a:ext cx="15555091" cy="7362825"/>
+            <a:off x="1028700" y="1562100"/>
+            <a:ext cx="15555091" cy="7153275"/>
           </a:xfrm>
           <a:prstGeom prst="rect">
             <a:avLst/>
@@ -3702,10 +3698,10 @@
                 <a:solidFill>
                   <a:srgbClr val="FFFAEF"/>
                 </a:solidFill>
-                <a:latin typeface="Jua"/>
-                <a:ea typeface="Jua"/>
-                <a:cs typeface="Jua"/>
-                <a:sym typeface="Jua"/>
+                <a:latin typeface="무궁화 고딕"/>
+                <a:ea typeface="무궁화 고딕"/>
+                <a:cs typeface="무궁화 고딕"/>
+                <a:sym typeface="무궁화 고딕"/>
               </a:rPr>
               <a:t>플러스(+) 단어 </a:t>
             </a:r>
@@ -3721,10 +3717,10 @@
                 <a:solidFill>
                   <a:srgbClr val="FFFAEF"/>
                 </a:solidFill>
-                <a:latin typeface="Jua"/>
-                <a:ea typeface="Jua"/>
-                <a:cs typeface="Jua"/>
-                <a:sym typeface="Jua"/>
+                <a:latin typeface="무궁화 고딕"/>
+                <a:ea typeface="무궁화 고딕"/>
+                <a:cs typeface="무궁화 고딕"/>
+                <a:sym typeface="무궁화 고딕"/>
               </a:rPr>
               <a:t>: 만나, 떡, 포도주, 빵, 물고기</a:t>
             </a:r>
@@ -3747,10 +3743,10 @@
                 <a:solidFill>
                   <a:srgbClr val="FFFAEF"/>
                 </a:solidFill>
-                <a:latin typeface="Jua"/>
-                <a:ea typeface="Jua"/>
-                <a:cs typeface="Jua"/>
-                <a:sym typeface="Jua"/>
+                <a:latin typeface="무궁화 고딕"/>
+                <a:ea typeface="무궁화 고딕"/>
+                <a:cs typeface="무궁화 고딕"/>
+                <a:sym typeface="무궁화 고딕"/>
               </a:rPr>
               <a:t>마이너스(-) 단어</a:t>
             </a:r>
@@ -3766,10 +3762,10 @@
                 <a:solidFill>
                   <a:srgbClr val="FFFAEF"/>
                 </a:solidFill>
-                <a:latin typeface="Jua"/>
-                <a:ea typeface="Jua"/>
-                <a:cs typeface="Jua"/>
-                <a:sym typeface="Jua"/>
+                <a:latin typeface="무궁화 고딕"/>
+                <a:ea typeface="무궁화 고딕"/>
+                <a:cs typeface="무궁화 고딕"/>
+                <a:sym typeface="무궁화 고딕"/>
               </a:rPr>
               <a:t>: 수박, 사과, 바나나</a:t>
             </a:r>
@@ -3784,8 +3780,8 @@
         </p:nvSpPr>
         <p:spPr>
           <a:xfrm rot="0">
-            <a:off x="15264803" y="9812655"/>
-            <a:ext cx="2637975" cy="474345"/>
+            <a:off x="15264803" y="9822180"/>
+            <a:ext cx="2637975" cy="941070"/>
           </a:xfrm>
           <a:prstGeom prst="rect">
             <a:avLst/>
@@ -3810,10 +3806,10 @@
                 <a:solidFill>
                   <a:srgbClr val="FFFFFF"/>
                 </a:solidFill>
-                <a:latin typeface="TDTD갬성명조"/>
-                <a:ea typeface="TDTD갬성명조"/>
-                <a:cs typeface="TDTD갬성명조"/>
-                <a:sym typeface="TDTD갬성명조"/>
+                <a:latin typeface="무궁화 고딕"/>
+                <a:ea typeface="무궁화 고딕"/>
+                <a:cs typeface="무궁화 고딕"/>
+                <a:sym typeface="무궁화 고딕"/>
               </a:rPr>
               <a:t>ⓒ 2026. Sunday Play</a:t>
             </a:r>
@@ -3860,8 +3856,8 @@
         </p:nvSpPr>
         <p:spPr>
           <a:xfrm rot="0">
-            <a:off x="1108788" y="3895725"/>
-            <a:ext cx="16070423" cy="2200275"/>
+            <a:off x="1108788" y="4181475"/>
+            <a:ext cx="16070423" cy="1914525"/>
           </a:xfrm>
           <a:prstGeom prst="rect">
             <a:avLst/>
@@ -3883,10 +3879,10 @@
                 <a:solidFill>
                   <a:srgbClr val="000000"/>
                 </a:solidFill>
-                <a:latin typeface="Jua"/>
-                <a:ea typeface="Jua"/>
-                <a:cs typeface="Jua"/>
-                <a:sym typeface="Jua"/>
+                <a:latin typeface="무궁화 고딕 Bold"/>
+                <a:ea typeface="무궁화 고딕 Bold"/>
+                <a:cs typeface="무궁화 고딕 Bold"/>
+                <a:sym typeface="무궁화 고딕 Bold"/>
               </a:rPr>
               <a:t>S로 시작하는 단어</a:t>
             </a:r>
@@ -4033,8 +4029,8 @@
         </p:nvSpPr>
         <p:spPr>
           <a:xfrm rot="0">
-            <a:off x="1028700" y="1352550"/>
-            <a:ext cx="15555091" cy="7362825"/>
+            <a:off x="1028700" y="1562100"/>
+            <a:ext cx="15555091" cy="7153275"/>
           </a:xfrm>
           <a:prstGeom prst="rect">
             <a:avLst/>
@@ -4056,10 +4052,10 @@
                 <a:solidFill>
                   <a:srgbClr val="FFFAEF"/>
                 </a:solidFill>
-                <a:latin typeface="Jua"/>
-                <a:ea typeface="Jua"/>
-                <a:cs typeface="Jua"/>
-                <a:sym typeface="Jua"/>
+                <a:latin typeface="무궁화 고딕"/>
+                <a:ea typeface="무궁화 고딕"/>
+                <a:cs typeface="무궁화 고딕"/>
+                <a:sym typeface="무궁화 고딕"/>
               </a:rPr>
               <a:t>플러스(+) 단어 </a:t>
             </a:r>
@@ -4075,10 +4071,10 @@
                 <a:solidFill>
                   <a:srgbClr val="FFFAEF"/>
                 </a:solidFill>
-                <a:latin typeface="Jua"/>
-                <a:ea typeface="Jua"/>
-                <a:cs typeface="Jua"/>
-                <a:sym typeface="Jua"/>
+                <a:latin typeface="무궁화 고딕"/>
+                <a:ea typeface="무궁화 고딕"/>
+                <a:cs typeface="무궁화 고딕"/>
+                <a:sym typeface="무궁화 고딕"/>
               </a:rPr>
               <a:t>: Sunday, Samuel, Solomon</a:t>
             </a:r>
@@ -4101,10 +4097,10 @@
                 <a:solidFill>
                   <a:srgbClr val="FFFAEF"/>
                 </a:solidFill>
-                <a:latin typeface="Jua"/>
-                <a:ea typeface="Jua"/>
-                <a:cs typeface="Jua"/>
-                <a:sym typeface="Jua"/>
+                <a:latin typeface="무궁화 고딕"/>
+                <a:ea typeface="무궁화 고딕"/>
+                <a:cs typeface="무궁화 고딕"/>
+                <a:sym typeface="무궁화 고딕"/>
               </a:rPr>
               <a:t>마이너스(-) 단어</a:t>
             </a:r>
@@ -4120,10 +4116,10 @@
                 <a:solidFill>
                   <a:srgbClr val="FFFAEF"/>
                 </a:solidFill>
-                <a:latin typeface="Jua"/>
-                <a:ea typeface="Jua"/>
-                <a:cs typeface="Jua"/>
-                <a:sym typeface="Jua"/>
+                <a:latin typeface="무궁화 고딕"/>
+                <a:ea typeface="무궁화 고딕"/>
+                <a:cs typeface="무궁화 고딕"/>
+                <a:sym typeface="무궁화 고딕"/>
               </a:rPr>
               <a:t>: Star, Snow, Song</a:t>
             </a:r>
@@ -4138,8 +4134,8 @@
         </p:nvSpPr>
         <p:spPr>
           <a:xfrm rot="0">
-            <a:off x="15264803" y="9812655"/>
-            <a:ext cx="2637975" cy="474345"/>
+            <a:off x="15264803" y="9822180"/>
+            <a:ext cx="2637975" cy="941070"/>
           </a:xfrm>
           <a:prstGeom prst="rect">
             <a:avLst/>
@@ -4164,10 +4160,10 @@
                 <a:solidFill>
                   <a:srgbClr val="FFFFFF"/>
                 </a:solidFill>
-                <a:latin typeface="TDTD갬성명조"/>
-                <a:ea typeface="TDTD갬성명조"/>
-                <a:cs typeface="TDTD갬성명조"/>
-                <a:sym typeface="TDTD갬성명조"/>
+                <a:latin typeface="무궁화 고딕"/>
+                <a:ea typeface="무궁화 고딕"/>
+                <a:cs typeface="무궁화 고딕"/>
+                <a:sym typeface="무궁화 고딕"/>
               </a:rPr>
               <a:t>ⓒ 2026. Sunday Play</a:t>
             </a:r>
@@ -4214,8 +4210,8 @@
         </p:nvSpPr>
         <p:spPr>
           <a:xfrm rot="0">
-            <a:off x="1108788" y="3895725"/>
-            <a:ext cx="16070423" cy="2200275"/>
+            <a:off x="1108788" y="4181475"/>
+            <a:ext cx="16070423" cy="1914525"/>
           </a:xfrm>
           <a:prstGeom prst="rect">
             <a:avLst/>
@@ -4237,10 +4233,10 @@
                 <a:solidFill>
                   <a:srgbClr val="000000"/>
                 </a:solidFill>
-                <a:latin typeface="Jua"/>
-                <a:ea typeface="Jua"/>
-                <a:cs typeface="Jua"/>
-                <a:sym typeface="Jua"/>
+                <a:latin typeface="무궁화 고딕 Bold"/>
+                <a:ea typeface="무궁화 고딕 Bold"/>
+                <a:cs typeface="무궁화 고딕 Bold"/>
+                <a:sym typeface="무궁화 고딕 Bold"/>
               </a:rPr>
               <a:t>동물 이름</a:t>
             </a:r>
@@ -4387,8 +4383,8 @@
         </p:nvSpPr>
         <p:spPr>
           <a:xfrm rot="0">
-            <a:off x="1028700" y="1352550"/>
-            <a:ext cx="15555091" cy="7362825"/>
+            <a:off x="1028700" y="1562100"/>
+            <a:ext cx="15555091" cy="7153275"/>
           </a:xfrm>
           <a:prstGeom prst="rect">
             <a:avLst/>
@@ -4410,10 +4406,10 @@
                 <a:solidFill>
                   <a:srgbClr val="FFFAEF"/>
                 </a:solidFill>
-                <a:latin typeface="Jua"/>
-                <a:ea typeface="Jua"/>
-                <a:cs typeface="Jua"/>
-                <a:sym typeface="Jua"/>
+                <a:latin typeface="무궁화 고딕"/>
+                <a:ea typeface="무궁화 고딕"/>
+                <a:cs typeface="무궁화 고딕"/>
+                <a:sym typeface="무궁화 고딕"/>
               </a:rPr>
               <a:t>플러스(+) 단어 </a:t>
             </a:r>
@@ -4429,10 +4425,10 @@
                 <a:solidFill>
                   <a:srgbClr val="FFFAEF"/>
                 </a:solidFill>
-                <a:latin typeface="Jua"/>
-                <a:ea typeface="Jua"/>
-                <a:cs typeface="Jua"/>
-                <a:sym typeface="Jua"/>
+                <a:latin typeface="무궁화 고딕"/>
+                <a:ea typeface="무궁화 고딕"/>
+                <a:cs typeface="무궁화 고딕"/>
+                <a:sym typeface="무궁화 고딕"/>
               </a:rPr>
               <a:t>: 비둘기, 양, 사자</a:t>
             </a:r>
@@ -4455,10 +4451,10 @@
                 <a:solidFill>
                   <a:srgbClr val="FFFAEF"/>
                 </a:solidFill>
-                <a:latin typeface="Jua"/>
-                <a:ea typeface="Jua"/>
-                <a:cs typeface="Jua"/>
-                <a:sym typeface="Jua"/>
+                <a:latin typeface="무궁화 고딕"/>
+                <a:ea typeface="무궁화 고딕"/>
+                <a:cs typeface="무궁화 고딕"/>
+                <a:sym typeface="무궁화 고딕"/>
               </a:rPr>
               <a:t>마이너스(-) 단어</a:t>
             </a:r>
@@ -4474,10 +4470,10 @@
                 <a:solidFill>
                   <a:srgbClr val="FFFAEF"/>
                 </a:solidFill>
-                <a:latin typeface="Jua"/>
-                <a:ea typeface="Jua"/>
-                <a:cs typeface="Jua"/>
-                <a:sym typeface="Jua"/>
+                <a:latin typeface="무궁화 고딕"/>
+                <a:ea typeface="무궁화 고딕"/>
+                <a:cs typeface="무궁화 고딕"/>
+                <a:sym typeface="무궁화 고딕"/>
               </a:rPr>
               <a:t>: 개, 고양이, 토끼</a:t>
             </a:r>
@@ -4492,8 +4488,8 @@
         </p:nvSpPr>
         <p:spPr>
           <a:xfrm rot="0">
-            <a:off x="15264803" y="9812655"/>
-            <a:ext cx="2637975" cy="474345"/>
+            <a:off x="15264803" y="9822180"/>
+            <a:ext cx="2637975" cy="941070"/>
           </a:xfrm>
           <a:prstGeom prst="rect">
             <a:avLst/>
@@ -4518,10 +4514,10 @@
                 <a:solidFill>
                   <a:srgbClr val="FFFFFF"/>
                 </a:solidFill>
-                <a:latin typeface="TDTD갬성명조"/>
-                <a:ea typeface="TDTD갬성명조"/>
-                <a:cs typeface="TDTD갬성명조"/>
-                <a:sym typeface="TDTD갬성명조"/>
+                <a:latin typeface="무궁화 고딕"/>
+                <a:ea typeface="무궁화 고딕"/>
+                <a:cs typeface="무궁화 고딕"/>
+                <a:sym typeface="무궁화 고딕"/>
               </a:rPr>
               <a:t>ⓒ 2026. Sunday Play</a:t>
             </a:r>
@@ -4568,8 +4564,8 @@
         </p:nvSpPr>
         <p:spPr>
           <a:xfrm rot="0">
-            <a:off x="1108788" y="3895725"/>
-            <a:ext cx="16070423" cy="2200275"/>
+            <a:off x="1108788" y="4181475"/>
+            <a:ext cx="16070423" cy="1914525"/>
           </a:xfrm>
           <a:prstGeom prst="rect">
             <a:avLst/>
@@ -4591,10 +4587,10 @@
                 <a:solidFill>
                   <a:srgbClr val="000000"/>
                 </a:solidFill>
-                <a:latin typeface="Jua"/>
-                <a:ea typeface="Jua"/>
-                <a:cs typeface="Jua"/>
-                <a:sym typeface="Jua"/>
+                <a:latin typeface="무궁화 고딕 Bold"/>
+                <a:ea typeface="무궁화 고딕 Bold"/>
+                <a:cs typeface="무궁화 고딕 Bold"/>
+                <a:sym typeface="무궁화 고딕 Bold"/>
               </a:rPr>
               <a:t>교회에서 볼 수 있는 물건</a:t>
             </a:r>
@@ -4741,8 +4737,8 @@
         </p:nvSpPr>
         <p:spPr>
           <a:xfrm rot="0">
-            <a:off x="1028700" y="1352550"/>
-            <a:ext cx="15555091" cy="7362825"/>
+            <a:off x="1028700" y="1562100"/>
+            <a:ext cx="15555091" cy="7153275"/>
           </a:xfrm>
           <a:prstGeom prst="rect">
             <a:avLst/>
@@ -4764,10 +4760,10 @@
                 <a:solidFill>
                   <a:srgbClr val="FFFAEF"/>
                 </a:solidFill>
-                <a:latin typeface="Jua"/>
-                <a:ea typeface="Jua"/>
-                <a:cs typeface="Jua"/>
-                <a:sym typeface="Jua"/>
+                <a:latin typeface="무궁화 고딕"/>
+                <a:ea typeface="무궁화 고딕"/>
+                <a:cs typeface="무궁화 고딕"/>
+                <a:sym typeface="무궁화 고딕"/>
               </a:rPr>
               <a:t>플러스(+) 단어 </a:t>
             </a:r>
@@ -4783,10 +4779,10 @@
                 <a:solidFill>
                   <a:srgbClr val="FFFAEF"/>
                 </a:solidFill>
-                <a:latin typeface="Jua"/>
-                <a:ea typeface="Jua"/>
-                <a:cs typeface="Jua"/>
-                <a:sym typeface="Jua"/>
+                <a:latin typeface="무궁화 고딕"/>
+                <a:ea typeface="무궁화 고딕"/>
+                <a:cs typeface="무궁화 고딕"/>
+                <a:sym typeface="무궁화 고딕"/>
               </a:rPr>
               <a:t>: 성경, 십자가, 찬송가</a:t>
             </a:r>
@@ -4809,10 +4805,10 @@
                 <a:solidFill>
                   <a:srgbClr val="FFFAEF"/>
                 </a:solidFill>
-                <a:latin typeface="Jua"/>
-                <a:ea typeface="Jua"/>
-                <a:cs typeface="Jua"/>
-                <a:sym typeface="Jua"/>
+                <a:latin typeface="무궁화 고딕"/>
+                <a:ea typeface="무궁화 고딕"/>
+                <a:cs typeface="무궁화 고딕"/>
+                <a:sym typeface="무궁화 고딕"/>
               </a:rPr>
               <a:t>마이너스(-) 단어</a:t>
             </a:r>
@@ -4828,10 +4824,10 @@
                 <a:solidFill>
                   <a:srgbClr val="FFFAEF"/>
                 </a:solidFill>
-                <a:latin typeface="Jua"/>
-                <a:ea typeface="Jua"/>
-                <a:cs typeface="Jua"/>
-                <a:sym typeface="Jua"/>
+                <a:latin typeface="무궁화 고딕"/>
+                <a:ea typeface="무궁화 고딕"/>
+                <a:cs typeface="무궁화 고딕"/>
+                <a:sym typeface="무궁화 고딕"/>
               </a:rPr>
               <a:t>: 의자, 시계, 마이크</a:t>
             </a:r>
@@ -4846,8 +4842,8 @@
         </p:nvSpPr>
         <p:spPr>
           <a:xfrm rot="0">
-            <a:off x="15264803" y="9812655"/>
-            <a:ext cx="2637975" cy="474345"/>
+            <a:off x="15264803" y="9822180"/>
+            <a:ext cx="2637975" cy="941070"/>
           </a:xfrm>
           <a:prstGeom prst="rect">
             <a:avLst/>
@@ -4872,10 +4868,10 @@
                 <a:solidFill>
                   <a:srgbClr val="FFFFFF"/>
                 </a:solidFill>
-                <a:latin typeface="TDTD갬성명조"/>
-                <a:ea typeface="TDTD갬성명조"/>
-                <a:cs typeface="TDTD갬성명조"/>
-                <a:sym typeface="TDTD갬성명조"/>
+                <a:latin typeface="무궁화 고딕"/>
+                <a:ea typeface="무궁화 고딕"/>
+                <a:cs typeface="무궁화 고딕"/>
+                <a:sym typeface="무궁화 고딕"/>
               </a:rPr>
               <a:t>ⓒ 2026. Sunday Play</a:t>
             </a:r>
@@ -4922,8 +4918,8 @@
         </p:nvSpPr>
         <p:spPr>
           <a:xfrm rot="0">
-            <a:off x="1108788" y="3895725"/>
-            <a:ext cx="16070423" cy="2200275"/>
+            <a:off x="1108788" y="4181475"/>
+            <a:ext cx="16070423" cy="1914525"/>
           </a:xfrm>
           <a:prstGeom prst="rect">
             <a:avLst/>
@@ -4945,10 +4941,10 @@
                 <a:solidFill>
                   <a:srgbClr val="000000"/>
                 </a:solidFill>
-                <a:latin typeface="Jua"/>
-                <a:ea typeface="Jua"/>
-                <a:cs typeface="Jua"/>
-                <a:sym typeface="Jua"/>
+                <a:latin typeface="무궁화 고딕 Bold"/>
+                <a:ea typeface="무궁화 고딕 Bold"/>
+                <a:cs typeface="무궁화 고딕 Bold"/>
+                <a:sym typeface="무궁화 고딕 Bold"/>
               </a:rPr>
               <a:t>L로 시작하는 단어</a:t>
             </a:r>
@@ -5147,8 +5143,8 @@
         </p:nvSpPr>
         <p:spPr>
           <a:xfrm rot="0">
-            <a:off x="11392761" y="600705"/>
-            <a:ext cx="5362043" cy="1600200"/>
+            <a:off x="11392761" y="819780"/>
+            <a:ext cx="5362043" cy="1381125"/>
           </a:xfrm>
           <a:prstGeom prst="rect">
             <a:avLst/>
@@ -5170,10 +5166,10 @@
                 <a:solidFill>
                   <a:srgbClr val="FFFAEF"/>
                 </a:solidFill>
-                <a:latin typeface="Jua"/>
-                <a:ea typeface="Jua"/>
-                <a:cs typeface="Jua"/>
-                <a:sym typeface="Jua"/>
+                <a:latin typeface="무궁화 고딕"/>
+                <a:ea typeface="무궁화 고딕"/>
+                <a:cs typeface="무궁화 고딕"/>
+                <a:sym typeface="무궁화 고딕"/>
               </a:rPr>
               <a:t>규칙</a:t>
             </a:r>
@@ -5189,9 +5185,9 @@
         <p:grpSpPr>
           <a:xfrm rot="0">
             <a:off x="246010" y="286490"/>
-            <a:ext cx="10108960" cy="3647369"/>
+            <a:ext cx="10108960" cy="3538461"/>
             <a:chOff x="0" y="0"/>
-            <a:chExt cx="13478613" cy="4863159"/>
+            <a:chExt cx="13478613" cy="4717948"/>
           </a:xfrm>
         </p:grpSpPr>
         <p:sp>
@@ -5202,8 +5198,8 @@
           </p:nvSpPr>
           <p:spPr>
             <a:xfrm rot="0">
-              <a:off x="0" y="1350128"/>
-              <a:ext cx="13478613" cy="3513032"/>
+              <a:off x="0" y="1360069"/>
+              <a:ext cx="13478613" cy="3357880"/>
             </a:xfrm>
             <a:prstGeom prst="rect">
               <a:avLst/>
@@ -5217,30 +5213,30 @@
             <a:p>
               <a:pPr algn="l">
                 <a:lnSpc>
-                  <a:spcPts val="5320"/>
+                  <a:spcPts val="5040"/>
                 </a:lnSpc>
               </a:pPr>
               <a:r>
-                <a:rPr lang="en-US" sz="3800">
+                <a:rPr lang="en-US" sz="3600">
                   <a:solidFill>
                     <a:srgbClr val="FFFAEF"/>
                   </a:solidFill>
-                  <a:latin typeface="TDTD가온"/>
-                  <a:ea typeface="TDTD가온"/>
-                  <a:cs typeface="TDTD가온"/>
-                  <a:sym typeface="TDTD가온"/>
+                  <a:latin typeface="무궁화 고딕"/>
+                  <a:ea typeface="무궁화 고딕"/>
+                  <a:cs typeface="무궁화 고딕"/>
+                  <a:sym typeface="무궁화 고딕"/>
                 </a:rPr>
                 <a:t>진행자가</a:t>
               </a:r>
               <a:r>
-                <a:rPr lang="en-US" sz="3800">
+                <a:rPr lang="en-US" sz="3600">
                   <a:solidFill>
                     <a:srgbClr val="FFFAEF"/>
                   </a:solidFill>
-                  <a:latin typeface="TDTD가온"/>
-                  <a:ea typeface="TDTD가온"/>
-                  <a:cs typeface="TDTD가온"/>
-                  <a:sym typeface="TDTD가온"/>
+                  <a:latin typeface="무궁화 고딕"/>
+                  <a:ea typeface="무궁화 고딕"/>
+                  <a:cs typeface="무궁화 고딕"/>
+                  <a:sym typeface="무궁화 고딕"/>
                 </a:rPr>
                 <a:t> 주제를 발표합니다.                                                                                 </a:t>
               </a:r>
@@ -5248,18 +5244,18 @@
             <a:p>
               <a:pPr algn="l">
                 <a:lnSpc>
-                  <a:spcPts val="5320"/>
+                  <a:spcPts val="5040"/>
                 </a:lnSpc>
               </a:pPr>
               <a:r>
-                <a:rPr lang="en-US" sz="3800">
+                <a:rPr lang="en-US" sz="3600">
                   <a:solidFill>
                     <a:srgbClr val="FFFAEF"/>
                   </a:solidFill>
-                  <a:latin typeface="TDTD가온"/>
-                  <a:ea typeface="TDTD가온"/>
-                  <a:cs typeface="TDTD가온"/>
-                  <a:sym typeface="TDTD가온"/>
+                  <a:latin typeface="무궁화 고딕"/>
+                  <a:ea typeface="무궁화 고딕"/>
+                  <a:cs typeface="무궁화 고딕"/>
+                  <a:sym typeface="무궁화 고딕"/>
                 </a:rPr>
                 <a:t> 예: "G로 시작하는 단어", "색깔 단어"                                                                            </a:t>
               </a:r>
@@ -5267,18 +5263,18 @@
             <a:p>
               <a:pPr algn="l">
                 <a:lnSpc>
-                  <a:spcPts val="5320"/>
+                  <a:spcPts val="5040"/>
                 </a:lnSpc>
               </a:pPr>
               <a:r>
-                <a:rPr lang="en-US" sz="3800">
+                <a:rPr lang="en-US" sz="3600">
                   <a:solidFill>
                     <a:srgbClr val="FFFAEF"/>
                   </a:solidFill>
-                  <a:latin typeface="TDTD가온"/>
-                  <a:ea typeface="TDTD가온"/>
-                  <a:cs typeface="TDTD가온"/>
-                  <a:sym typeface="TDTD가온"/>
+                  <a:latin typeface="무궁화 고딕"/>
+                  <a:ea typeface="무궁화 고딕"/>
+                  <a:cs typeface="무궁화 고딕"/>
+                  <a:sym typeface="무궁화 고딕"/>
                 </a:rPr>
                 <a:t> 제한 시간(1분) 내에 단어를 최대한 많이 적으세요!</a:t>
               </a:r>
@@ -5286,7 +5282,7 @@
             <a:p>
               <a:pPr algn="l">
                 <a:lnSpc>
-                  <a:spcPts val="5320"/>
+                  <a:spcPts val="5040"/>
                 </a:lnSpc>
               </a:pPr>
             </a:p>
@@ -5300,8 +5296,8 @@
           </p:nvSpPr>
           <p:spPr>
             <a:xfrm rot="0">
-              <a:off x="0" y="-152400"/>
-              <a:ext cx="10684245" cy="1065427"/>
+              <a:off x="0" y="-47625"/>
+              <a:ext cx="10684245" cy="961068"/>
             </a:xfrm>
             <a:prstGeom prst="rect">
               <a:avLst/>
@@ -5323,10 +5319,10 @@
                   <a:solidFill>
                     <a:srgbClr val="FFFAEF"/>
                   </a:solidFill>
-                  <a:latin typeface="Jua"/>
-                  <a:ea typeface="Jua"/>
-                  <a:cs typeface="Jua"/>
-                  <a:sym typeface="Jua"/>
+                  <a:latin typeface="무궁화 고딕 Bold"/>
+                  <a:ea typeface="무궁화 고딕 Bold"/>
+                  <a:cs typeface="무궁화 고딕 Bold"/>
+                  <a:sym typeface="무궁화 고딕 Bold"/>
                 </a:rPr>
                 <a:t>STEP 1.</a:t>
               </a:r>
@@ -5343,9 +5339,9 @@
         <p:grpSpPr>
           <a:xfrm rot="0">
             <a:off x="10064338" y="7720060"/>
-            <a:ext cx="8552074" cy="2967261"/>
+            <a:ext cx="8552074" cy="2886615"/>
             <a:chOff x="0" y="0"/>
-            <a:chExt cx="11402765" cy="3956347"/>
+            <a:chExt cx="11402765" cy="3848821"/>
           </a:xfrm>
         </p:grpSpPr>
         <p:sp>
@@ -5356,8 +5352,8 @@
           </p:nvSpPr>
           <p:spPr>
             <a:xfrm rot="0">
-              <a:off x="0" y="1332315"/>
-              <a:ext cx="11402765" cy="2624033"/>
+              <a:off x="0" y="1341840"/>
+              <a:ext cx="11402765" cy="2506981"/>
             </a:xfrm>
             <a:prstGeom prst="rect">
               <a:avLst/>
@@ -5371,30 +5367,30 @@
             <a:p>
               <a:pPr algn="l">
                 <a:lnSpc>
-                  <a:spcPts val="5319"/>
+                  <a:spcPts val="5039"/>
                 </a:lnSpc>
               </a:pPr>
               <a:r>
-                <a:rPr lang="en-US" sz="3799">
+                <a:rPr lang="en-US" sz="3599">
                   <a:solidFill>
                     <a:srgbClr val="FFFAEF"/>
                   </a:solidFill>
-                  <a:latin typeface="TDTD가온"/>
-                  <a:ea typeface="TDTD가온"/>
-                  <a:cs typeface="TDTD가온"/>
-                  <a:sym typeface="TDTD가온"/>
+                  <a:latin typeface="무궁화 고딕"/>
+                  <a:ea typeface="무궁화 고딕"/>
+                  <a:cs typeface="무궁화 고딕"/>
+                  <a:sym typeface="무궁화 고딕"/>
                 </a:rPr>
                 <a:t>화이트보</a:t>
               </a:r>
               <a:r>
-                <a:rPr lang="en-US" sz="3799">
+                <a:rPr lang="en-US" sz="3599">
                   <a:solidFill>
                     <a:srgbClr val="FFFAEF"/>
                   </a:solidFill>
-                  <a:latin typeface="TDTD가온"/>
-                  <a:ea typeface="TDTD가온"/>
-                  <a:cs typeface="TDTD가온"/>
-                  <a:sym typeface="TDTD가온"/>
+                  <a:latin typeface="무궁화 고딕"/>
+                  <a:ea typeface="무궁화 고딕"/>
+                  <a:cs typeface="무궁화 고딕"/>
+                  <a:sym typeface="무궁화 고딕"/>
                 </a:rPr>
                 <a:t>드를 동시에 공개!                                                                                  </a:t>
               </a:r>
@@ -5402,26 +5398,26 @@
             <a:p>
               <a:pPr algn="l">
                 <a:lnSpc>
-                  <a:spcPts val="5319"/>
+                  <a:spcPts val="5039"/>
                 </a:lnSpc>
               </a:pPr>
               <a:r>
-                <a:rPr lang="en-US" sz="3799">
+                <a:rPr lang="en-US" sz="3599">
                   <a:solidFill>
                     <a:srgbClr val="FFFAEF"/>
                   </a:solidFill>
-                  <a:latin typeface="TDTD가온"/>
-                  <a:ea typeface="TDTD가온"/>
-                  <a:cs typeface="TDTD가온"/>
-                  <a:sym typeface="TDTD가온"/>
+                  <a:latin typeface="무궁화 고딕"/>
+                  <a:ea typeface="무궁화 고딕"/>
+                  <a:cs typeface="무궁화 고딕"/>
+                  <a:sym typeface="무궁화 고딕"/>
                 </a:rPr>
-                <a:t> 일반 단어 1점, 플러스 +5점, 마이너스 -3점! </a:t>
+                <a:t>일반 단어 1점, 플러스 +5점, 마이너스 -3점! </a:t>
               </a:r>
             </a:p>
             <a:p>
               <a:pPr algn="l">
                 <a:lnSpc>
-                  <a:spcPts val="5319"/>
+                  <a:spcPts val="5039"/>
                 </a:lnSpc>
               </a:pPr>
             </a:p>
@@ -5435,8 +5431,8 @@
           </p:nvSpPr>
           <p:spPr>
             <a:xfrm rot="0">
-              <a:off x="0" y="-161925"/>
-              <a:ext cx="11402765" cy="1063625"/>
+              <a:off x="0" y="-47625"/>
+              <a:ext cx="11402765" cy="949325"/>
             </a:xfrm>
             <a:prstGeom prst="rect">
               <a:avLst/>
@@ -5458,10 +5454,10 @@
                   <a:solidFill>
                     <a:srgbClr val="FFFAEF"/>
                   </a:solidFill>
-                  <a:latin typeface="Jua"/>
-                  <a:ea typeface="Jua"/>
-                  <a:cs typeface="Jua"/>
-                  <a:sym typeface="Jua"/>
+                  <a:latin typeface="무궁화 고딕 Bold"/>
+                  <a:ea typeface="무궁화 고딕 Bold"/>
+                  <a:cs typeface="무궁화 고딕 Bold"/>
+                  <a:sym typeface="무궁화 고딕 Bold"/>
                 </a:rPr>
                 <a:t>STEP 3.</a:t>
               </a:r>
@@ -5478,9 +5474,9 @@
         <p:grpSpPr>
           <a:xfrm rot="0">
             <a:off x="4296463" y="3938729"/>
-            <a:ext cx="10466970" cy="3634011"/>
+            <a:ext cx="10466970" cy="3524790"/>
             <a:chOff x="0" y="0"/>
-            <a:chExt cx="13955960" cy="4845347"/>
+            <a:chExt cx="13955960" cy="4699721"/>
           </a:xfrm>
         </p:grpSpPr>
         <p:sp>
@@ -5491,8 +5487,8 @@
           </p:nvSpPr>
           <p:spPr>
             <a:xfrm rot="0">
-              <a:off x="0" y="1332315"/>
-              <a:ext cx="13955960" cy="3513033"/>
+              <a:off x="0" y="1341840"/>
+              <a:ext cx="13955960" cy="3357881"/>
             </a:xfrm>
             <a:prstGeom prst="rect">
               <a:avLst/>
@@ -5506,18 +5502,18 @@
             <a:p>
               <a:pPr algn="l">
                 <a:lnSpc>
-                  <a:spcPts val="5319"/>
+                  <a:spcPts val="5039"/>
                 </a:lnSpc>
               </a:pPr>
               <a:r>
-                <a:rPr lang="en-US" sz="3799">
+                <a:rPr lang="en-US" sz="3599">
                   <a:solidFill>
                     <a:srgbClr val="FFFAEF"/>
                   </a:solidFill>
-                  <a:latin typeface="TDTD가온"/>
-                  <a:ea typeface="TDTD가온"/>
-                  <a:cs typeface="TDTD가온"/>
-                  <a:sym typeface="TDTD가온"/>
+                  <a:latin typeface="무궁화 고딕"/>
+                  <a:ea typeface="무궁화 고딕"/>
+                  <a:cs typeface="무궁화 고딕"/>
+                  <a:sym typeface="무궁화 고딕"/>
                 </a:rPr>
                 <a:t>시간 종료! 진행자가 플러스/마이너스 단어를 공개합니다.                                                                   </a:t>
               </a:r>
@@ -5525,18 +5521,18 @@
             <a:p>
               <a:pPr algn="l">
                 <a:lnSpc>
-                  <a:spcPts val="5319"/>
+                  <a:spcPts val="5039"/>
                 </a:lnSpc>
               </a:pPr>
               <a:r>
-                <a:rPr lang="en-US" sz="3799">
+                <a:rPr lang="en-US" sz="3599">
                   <a:solidFill>
                     <a:srgbClr val="FFFAEF"/>
                   </a:solidFill>
-                  <a:latin typeface="TDTD가온"/>
-                  <a:ea typeface="TDTD가온"/>
-                  <a:cs typeface="TDTD가온"/>
-                  <a:sym typeface="TDTD가온"/>
+                  <a:latin typeface="무궁화 고딕"/>
+                  <a:ea typeface="무궁화 고딕"/>
+                  <a:cs typeface="무궁화 고딕"/>
+                  <a:sym typeface="무궁화 고딕"/>
                 </a:rPr>
                 <a:t> 플러스(+5점): God, Good, Gift                                                                                </a:t>
               </a:r>
@@ -5544,18 +5540,18 @@
             <a:p>
               <a:pPr algn="l">
                 <a:lnSpc>
-                  <a:spcPts val="5319"/>
+                  <a:spcPts val="5039"/>
                 </a:lnSpc>
               </a:pPr>
               <a:r>
-                <a:rPr lang="en-US" sz="3799">
+                <a:rPr lang="en-US" sz="3599">
                   <a:solidFill>
                     <a:srgbClr val="FFFAEF"/>
                   </a:solidFill>
-                  <a:latin typeface="TDTD가온"/>
-                  <a:ea typeface="TDTD가온"/>
-                  <a:cs typeface="TDTD가온"/>
-                  <a:sym typeface="TDTD가온"/>
+                  <a:latin typeface="무궁화 고딕"/>
+                  <a:ea typeface="무궁화 고딕"/>
+                  <a:cs typeface="무궁화 고딕"/>
+                  <a:sym typeface="무궁화 고딕"/>
                 </a:rPr>
                 <a:t> 마이너스(-3점): Give, Great, Garden     </a:t>
               </a:r>
@@ -5563,7 +5559,7 @@
             <a:p>
               <a:pPr algn="l">
                 <a:lnSpc>
-                  <a:spcPts val="5319"/>
+                  <a:spcPts val="5039"/>
                 </a:lnSpc>
               </a:pPr>
             </a:p>
@@ -5577,8 +5573,8 @@
           </p:nvSpPr>
           <p:spPr>
             <a:xfrm rot="0">
-              <a:off x="0" y="-161925"/>
-              <a:ext cx="10551700" cy="1063625"/>
+              <a:off x="0" y="-47625"/>
+              <a:ext cx="10551700" cy="949325"/>
             </a:xfrm>
             <a:prstGeom prst="rect">
               <a:avLst/>
@@ -5600,10 +5596,10 @@
                   <a:solidFill>
                     <a:srgbClr val="FFFAEF"/>
                   </a:solidFill>
-                  <a:latin typeface="Jua"/>
-                  <a:ea typeface="Jua"/>
-                  <a:cs typeface="Jua"/>
-                  <a:sym typeface="Jua"/>
+                  <a:latin typeface="무궁화 고딕 Bold"/>
+                  <a:ea typeface="무궁화 고딕 Bold"/>
+                  <a:cs typeface="무궁화 고딕 Bold"/>
+                  <a:sym typeface="무궁화 고딕 Bold"/>
                 </a:rPr>
                 <a:t>STEP 2.</a:t>
               </a:r>
@@ -5701,8 +5697,8 @@
         </p:nvSpPr>
         <p:spPr>
           <a:xfrm rot="0">
-            <a:off x="1028700" y="1352550"/>
-            <a:ext cx="15555091" cy="7362825"/>
+            <a:off x="1028700" y="1562100"/>
+            <a:ext cx="15555091" cy="7153275"/>
           </a:xfrm>
           <a:prstGeom prst="rect">
             <a:avLst/>
@@ -5724,10 +5720,10 @@
                 <a:solidFill>
                   <a:srgbClr val="FFFAEF"/>
                 </a:solidFill>
-                <a:latin typeface="Jua"/>
-                <a:ea typeface="Jua"/>
-                <a:cs typeface="Jua"/>
-                <a:sym typeface="Jua"/>
+                <a:latin typeface="무궁화 고딕"/>
+                <a:ea typeface="무궁화 고딕"/>
+                <a:cs typeface="무궁화 고딕"/>
+                <a:sym typeface="무궁화 고딕"/>
               </a:rPr>
               <a:t>플러스(+) 단어 </a:t>
             </a:r>
@@ -5743,10 +5739,10 @@
                 <a:solidFill>
                   <a:srgbClr val="FFFAEF"/>
                 </a:solidFill>
-                <a:latin typeface="Jua"/>
-                <a:ea typeface="Jua"/>
-                <a:cs typeface="Jua"/>
-                <a:sym typeface="Jua"/>
+                <a:latin typeface="무궁화 고딕"/>
+                <a:ea typeface="무궁화 고딕"/>
+                <a:cs typeface="무궁화 고딕"/>
+                <a:sym typeface="무궁화 고딕"/>
               </a:rPr>
               <a:t>: Love, Light, Lord</a:t>
             </a:r>
@@ -5769,10 +5765,10 @@
                 <a:solidFill>
                   <a:srgbClr val="FFFAEF"/>
                 </a:solidFill>
-                <a:latin typeface="Jua"/>
-                <a:ea typeface="Jua"/>
-                <a:cs typeface="Jua"/>
-                <a:sym typeface="Jua"/>
+                <a:latin typeface="무궁화 고딕"/>
+                <a:ea typeface="무궁화 고딕"/>
+                <a:cs typeface="무궁화 고딕"/>
+                <a:sym typeface="무궁화 고딕"/>
               </a:rPr>
               <a:t>마이너스(-) 단어</a:t>
             </a:r>
@@ -5788,10 +5784,10 @@
                 <a:solidFill>
                   <a:srgbClr val="FFFAEF"/>
                 </a:solidFill>
-                <a:latin typeface="Jua"/>
-                <a:ea typeface="Jua"/>
-                <a:cs typeface="Jua"/>
-                <a:sym typeface="Jua"/>
+                <a:latin typeface="무궁화 고딕"/>
+                <a:ea typeface="무궁화 고딕"/>
+                <a:cs typeface="무궁화 고딕"/>
+                <a:sym typeface="무궁화 고딕"/>
               </a:rPr>
               <a:t>: Lion, Lake, Lamp</a:t>
             </a:r>
@@ -5806,8 +5802,8 @@
         </p:nvSpPr>
         <p:spPr>
           <a:xfrm rot="0">
-            <a:off x="15264803" y="9812655"/>
-            <a:ext cx="2637975" cy="474345"/>
+            <a:off x="15264803" y="9822180"/>
+            <a:ext cx="2637975" cy="941070"/>
           </a:xfrm>
           <a:prstGeom prst="rect">
             <a:avLst/>
@@ -5832,10 +5828,10 @@
                 <a:solidFill>
                   <a:srgbClr val="FFFFFF"/>
                 </a:solidFill>
-                <a:latin typeface="TDTD갬성명조"/>
-                <a:ea typeface="TDTD갬성명조"/>
-                <a:cs typeface="TDTD갬성명조"/>
-                <a:sym typeface="TDTD갬성명조"/>
+                <a:latin typeface="무궁화 고딕"/>
+                <a:ea typeface="무궁화 고딕"/>
+                <a:cs typeface="무궁화 고딕"/>
+                <a:sym typeface="무궁화 고딕"/>
               </a:rPr>
               <a:t>ⓒ 2026. Sunday Play</a:t>
             </a:r>
@@ -5907,8 +5903,8 @@
         </p:nvSpPr>
         <p:spPr>
           <a:xfrm rot="0">
-            <a:off x="4421807" y="3895725"/>
-            <a:ext cx="9444385" cy="2200275"/>
+            <a:off x="4421807" y="4181475"/>
+            <a:ext cx="9444385" cy="1914525"/>
           </a:xfrm>
           <a:prstGeom prst="rect">
             <a:avLst/>
@@ -5930,10 +5926,10 @@
                 <a:solidFill>
                   <a:srgbClr val="000000"/>
                 </a:solidFill>
-                <a:latin typeface="Jua"/>
-                <a:ea typeface="Jua"/>
-                <a:cs typeface="Jua"/>
-                <a:sym typeface="Jua"/>
+                <a:latin typeface="무궁화 고딕"/>
+                <a:ea typeface="무궁화 고딕"/>
+                <a:cs typeface="무궁화 고딕"/>
+                <a:sym typeface="무궁화 고딕"/>
               </a:rPr>
               <a:t>감사합니다!</a:t>
             </a:r>
@@ -6030,8 +6026,8 @@
         </p:nvSpPr>
         <p:spPr>
           <a:xfrm rot="0">
-            <a:off x="3238925" y="4092795"/>
-            <a:ext cx="11810151" cy="2200275"/>
+            <a:off x="3238925" y="4378545"/>
+            <a:ext cx="11810151" cy="1914525"/>
           </a:xfrm>
           <a:prstGeom prst="rect">
             <a:avLst/>
@@ -6053,10 +6049,10 @@
                 <a:solidFill>
                   <a:srgbClr val="000000"/>
                 </a:solidFill>
-                <a:latin typeface="Jua"/>
-                <a:ea typeface="Jua"/>
-                <a:cs typeface="Jua"/>
-                <a:sym typeface="Jua"/>
+                <a:latin typeface="무궁화 고딕"/>
+                <a:ea typeface="무궁화 고딕"/>
+                <a:cs typeface="무궁화 고딕"/>
+                <a:sym typeface="무궁화 고딕"/>
               </a:rPr>
               <a:t>팀을 나눠주세요!</a:t>
             </a:r>
@@ -6203,8 +6199,8 @@
         </p:nvSpPr>
         <p:spPr>
           <a:xfrm rot="0">
-            <a:off x="1028700" y="3892867"/>
-            <a:ext cx="15555091" cy="2200275"/>
+            <a:off x="1028700" y="4178617"/>
+            <a:ext cx="15555091" cy="1914525"/>
           </a:xfrm>
           <a:prstGeom prst="rect">
             <a:avLst/>
@@ -6226,10 +6222,10 @@
                 <a:solidFill>
                   <a:srgbClr val="FFFAEF"/>
                 </a:solidFill>
-                <a:latin typeface="Jua"/>
-                <a:ea typeface="Jua"/>
-                <a:cs typeface="Jua"/>
-                <a:sym typeface="Jua"/>
+                <a:latin typeface="무궁화 고딕"/>
+                <a:ea typeface="무궁화 고딕"/>
+                <a:cs typeface="무궁화 고딕"/>
+                <a:sym typeface="무궁화 고딕"/>
               </a:rPr>
               <a:t>단어 스피드 퀴즈</a:t>
             </a:r>
@@ -6244,8 +6240,8 @@
         </p:nvSpPr>
         <p:spPr>
           <a:xfrm rot="0">
-            <a:off x="15264803" y="9812655"/>
-            <a:ext cx="2637975" cy="474345"/>
+            <a:off x="14823645" y="9822180"/>
+            <a:ext cx="3079133" cy="464820"/>
           </a:xfrm>
           <a:prstGeom prst="rect">
             <a:avLst/>
@@ -6270,10 +6266,10 @@
                 <a:solidFill>
                   <a:srgbClr val="FFFFFF"/>
                 </a:solidFill>
-                <a:latin typeface="TDTD갬성명조"/>
-                <a:ea typeface="TDTD갬성명조"/>
-                <a:cs typeface="TDTD갬성명조"/>
-                <a:sym typeface="TDTD갬성명조"/>
+                <a:latin typeface="무궁화 고딕"/>
+                <a:ea typeface="무궁화 고딕"/>
+                <a:cs typeface="무궁화 고딕"/>
+                <a:sym typeface="무궁화 고딕"/>
               </a:rPr>
               <a:t>ⓒ 2026. Sunday Play</a:t>
             </a:r>
@@ -6320,8 +6316,8 @@
         </p:nvSpPr>
         <p:spPr>
           <a:xfrm rot="0">
-            <a:off x="1108788" y="3895725"/>
-            <a:ext cx="16070423" cy="2200275"/>
+            <a:off x="1108788" y="4181475"/>
+            <a:ext cx="16070423" cy="1914525"/>
           </a:xfrm>
           <a:prstGeom prst="rect">
             <a:avLst/>
@@ -6343,10 +6339,10 @@
                 <a:solidFill>
                   <a:srgbClr val="000000"/>
                 </a:solidFill>
-                <a:latin typeface="Jua"/>
-                <a:ea typeface="Jua"/>
-                <a:cs typeface="Jua"/>
-                <a:sym typeface="Jua"/>
+                <a:latin typeface="무궁화 고딕 Bold"/>
+                <a:ea typeface="무궁화 고딕 Bold"/>
+                <a:cs typeface="무궁화 고딕 Bold"/>
+                <a:sym typeface="무궁화 고딕 Bold"/>
               </a:rPr>
               <a:t>G로 시작하는 단어</a:t>
             </a:r>
@@ -6493,8 +6489,8 @@
         </p:nvSpPr>
         <p:spPr>
           <a:xfrm rot="0">
-            <a:off x="1028700" y="1349692"/>
-            <a:ext cx="15555091" cy="7362825"/>
+            <a:off x="1028700" y="1559242"/>
+            <a:ext cx="15555091" cy="7153275"/>
           </a:xfrm>
           <a:prstGeom prst="rect">
             <a:avLst/>
@@ -6516,10 +6512,10 @@
                 <a:solidFill>
                   <a:srgbClr val="FFFAEF"/>
                 </a:solidFill>
-                <a:latin typeface="Jua"/>
-                <a:ea typeface="Jua"/>
-                <a:cs typeface="Jua"/>
-                <a:sym typeface="Jua"/>
+                <a:latin typeface="무궁화 고딕"/>
+                <a:ea typeface="무궁화 고딕"/>
+                <a:cs typeface="무궁화 고딕"/>
+                <a:sym typeface="무궁화 고딕"/>
               </a:rPr>
               <a:t>플러스(+) 단어 </a:t>
             </a:r>
@@ -6535,10 +6531,10 @@
                 <a:solidFill>
                   <a:srgbClr val="FFFAEF"/>
                 </a:solidFill>
-                <a:latin typeface="Jua"/>
-                <a:ea typeface="Jua"/>
-                <a:cs typeface="Jua"/>
-                <a:sym typeface="Jua"/>
+                <a:latin typeface="무궁화 고딕"/>
+                <a:ea typeface="무궁화 고딕"/>
+                <a:cs typeface="무궁화 고딕"/>
+                <a:sym typeface="무궁화 고딕"/>
               </a:rPr>
               <a:t>: God, Good, Gift</a:t>
             </a:r>
@@ -6561,10 +6557,10 @@
                 <a:solidFill>
                   <a:srgbClr val="FFFAEF"/>
                 </a:solidFill>
-                <a:latin typeface="Jua"/>
-                <a:ea typeface="Jua"/>
-                <a:cs typeface="Jua"/>
-                <a:sym typeface="Jua"/>
+                <a:latin typeface="무궁화 고딕"/>
+                <a:ea typeface="무궁화 고딕"/>
+                <a:cs typeface="무궁화 고딕"/>
+                <a:sym typeface="무궁화 고딕"/>
               </a:rPr>
               <a:t>마이너스(-) 단어</a:t>
             </a:r>
@@ -6580,10 +6576,10 @@
                 <a:solidFill>
                   <a:srgbClr val="FFFAEF"/>
                 </a:solidFill>
-                <a:latin typeface="Jua"/>
-                <a:ea typeface="Jua"/>
-                <a:cs typeface="Jua"/>
-                <a:sym typeface="Jua"/>
+                <a:latin typeface="무궁화 고딕"/>
+                <a:ea typeface="무궁화 고딕"/>
+                <a:cs typeface="무궁화 고딕"/>
+                <a:sym typeface="무궁화 고딕"/>
               </a:rPr>
               <a:t>: Give, Great, Garden</a:t>
             </a:r>
@@ -6598,8 +6594,8 @@
         </p:nvSpPr>
         <p:spPr>
           <a:xfrm rot="0">
-            <a:off x="15264803" y="9812655"/>
-            <a:ext cx="2637975" cy="474345"/>
+            <a:off x="15264803" y="9822180"/>
+            <a:ext cx="2637975" cy="941070"/>
           </a:xfrm>
           <a:prstGeom prst="rect">
             <a:avLst/>
@@ -6624,10 +6620,10 @@
                 <a:solidFill>
                   <a:srgbClr val="FFFFFF"/>
                 </a:solidFill>
-                <a:latin typeface="TDTD갬성명조"/>
-                <a:ea typeface="TDTD갬성명조"/>
-                <a:cs typeface="TDTD갬성명조"/>
-                <a:sym typeface="TDTD갬성명조"/>
+                <a:latin typeface="무궁화 고딕"/>
+                <a:ea typeface="무궁화 고딕"/>
+                <a:cs typeface="무궁화 고딕"/>
+                <a:sym typeface="무궁화 고딕"/>
               </a:rPr>
               <a:t>ⓒ 2026. Sunday Play</a:t>
             </a:r>
@@ -6674,8 +6670,8 @@
         </p:nvSpPr>
         <p:spPr>
           <a:xfrm rot="0">
-            <a:off x="1108788" y="3895725"/>
-            <a:ext cx="16070423" cy="2200275"/>
+            <a:off x="1108788" y="4181475"/>
+            <a:ext cx="16070423" cy="1914525"/>
           </a:xfrm>
           <a:prstGeom prst="rect">
             <a:avLst/>
@@ -6697,10 +6693,10 @@
                 <a:solidFill>
                   <a:srgbClr val="000000"/>
                 </a:solidFill>
-                <a:latin typeface="Jua"/>
-                <a:ea typeface="Jua"/>
-                <a:cs typeface="Jua"/>
-                <a:sym typeface="Jua"/>
+                <a:latin typeface="무궁화 고딕 Bold"/>
+                <a:ea typeface="무궁화 고딕 Bold"/>
+                <a:cs typeface="무궁화 고딕 Bold"/>
+                <a:sym typeface="무궁화 고딕 Bold"/>
               </a:rPr>
               <a:t>색깔 단어</a:t>
             </a:r>
@@ -6847,8 +6843,8 @@
         </p:nvSpPr>
         <p:spPr>
           <a:xfrm rot="0">
-            <a:off x="1028700" y="1352550"/>
-            <a:ext cx="15555091" cy="7362825"/>
+            <a:off x="1028700" y="1562100"/>
+            <a:ext cx="15555091" cy="7153275"/>
           </a:xfrm>
           <a:prstGeom prst="rect">
             <a:avLst/>
@@ -6870,10 +6866,10 @@
                 <a:solidFill>
                   <a:srgbClr val="FFFAEF"/>
                 </a:solidFill>
-                <a:latin typeface="Jua"/>
-                <a:ea typeface="Jua"/>
-                <a:cs typeface="Jua"/>
-                <a:sym typeface="Jua"/>
+                <a:latin typeface="무궁화 고딕"/>
+                <a:ea typeface="무궁화 고딕"/>
+                <a:cs typeface="무궁화 고딕"/>
+                <a:sym typeface="무궁화 고딕"/>
               </a:rPr>
               <a:t>플러스(+) 단어 </a:t>
             </a:r>
@@ -6889,10 +6885,10 @@
                 <a:solidFill>
                   <a:srgbClr val="FFFAEF"/>
                 </a:solidFill>
-                <a:latin typeface="Jua"/>
-                <a:ea typeface="Jua"/>
-                <a:cs typeface="Jua"/>
-                <a:sym typeface="Jua"/>
+                <a:latin typeface="무궁화 고딕"/>
+                <a:ea typeface="무궁화 고딕"/>
+                <a:cs typeface="무궁화 고딕"/>
+                <a:sym typeface="무궁화 고딕"/>
               </a:rPr>
               <a:t>: 하늘색, 금색, 빨강</a:t>
             </a:r>
@@ -6915,10 +6911,10 @@
                 <a:solidFill>
                   <a:srgbClr val="FFFAEF"/>
                 </a:solidFill>
-                <a:latin typeface="Jua"/>
-                <a:ea typeface="Jua"/>
-                <a:cs typeface="Jua"/>
-                <a:sym typeface="Jua"/>
+                <a:latin typeface="무궁화 고딕"/>
+                <a:ea typeface="무궁화 고딕"/>
+                <a:cs typeface="무궁화 고딕"/>
+                <a:sym typeface="무궁화 고딕"/>
               </a:rPr>
               <a:t>마이너스(-) 단어</a:t>
             </a:r>
@@ -6934,10 +6930,10 @@
                 <a:solidFill>
                   <a:srgbClr val="FFFAEF"/>
                 </a:solidFill>
-                <a:latin typeface="Jua"/>
-                <a:ea typeface="Jua"/>
-                <a:cs typeface="Jua"/>
-                <a:sym typeface="Jua"/>
+                <a:latin typeface="무궁화 고딕"/>
+                <a:ea typeface="무궁화 고딕"/>
+                <a:cs typeface="무궁화 고딕"/>
+                <a:sym typeface="무궁화 고딕"/>
               </a:rPr>
               <a:t>: 노랑, 파랑, 검정</a:t>
             </a:r>
@@ -6952,8 +6948,8 @@
         </p:nvSpPr>
         <p:spPr>
           <a:xfrm rot="0">
-            <a:off x="15264803" y="9812655"/>
-            <a:ext cx="2637975" cy="474345"/>
+            <a:off x="15264803" y="9822180"/>
+            <a:ext cx="2637975" cy="941070"/>
           </a:xfrm>
           <a:prstGeom prst="rect">
             <a:avLst/>
@@ -6978,10 +6974,10 @@
                 <a:solidFill>
                   <a:srgbClr val="FFFFFF"/>
                 </a:solidFill>
-                <a:latin typeface="TDTD갬성명조"/>
-                <a:ea typeface="TDTD갬성명조"/>
-                <a:cs typeface="TDTD갬성명조"/>
-                <a:sym typeface="TDTD갬성명조"/>
+                <a:latin typeface="무궁화 고딕"/>
+                <a:ea typeface="무궁화 고딕"/>
+                <a:cs typeface="무궁화 고딕"/>
+                <a:sym typeface="무궁화 고딕"/>
               </a:rPr>
               <a:t>ⓒ 2026. Sunday Play</a:t>
             </a:r>
@@ -7028,8 +7024,8 @@
         </p:nvSpPr>
         <p:spPr>
           <a:xfrm rot="0">
-            <a:off x="1108788" y="3895725"/>
-            <a:ext cx="16070423" cy="2200275"/>
+            <a:off x="1108788" y="4181475"/>
+            <a:ext cx="16070423" cy="1914525"/>
           </a:xfrm>
           <a:prstGeom prst="rect">
             <a:avLst/>
@@ -7051,10 +7047,10 @@
                 <a:solidFill>
                   <a:srgbClr val="000000"/>
                 </a:solidFill>
-                <a:latin typeface="Jua"/>
-                <a:ea typeface="Jua"/>
-                <a:cs typeface="Jua"/>
-                <a:sym typeface="Jua"/>
+                <a:latin typeface="무궁화 고딕 Bold"/>
+                <a:ea typeface="무궁화 고딕 Bold"/>
+                <a:cs typeface="무궁화 고딕 Bold"/>
+                <a:sym typeface="무궁화 고딕 Bold"/>
               </a:rPr>
               <a:t>교회에서 하는 행동</a:t>
             </a:r>

</xml_diff>